<commit_message>
Phase 7: final cross-check, number alignment, README
Co-Authored-By: Claude Opus 5.5 <noreply@anthropic.com>
Claude-Session: https://claude.ai/code/session_01NmoLfXKPfaPcQvVgdZPgcG
</commit_message>
<xml_diff>
--- a/deck/pitch_deck.pptx
+++ b/deck/pitch_deck.pptx
@@ -796,7 +796,7 @@
           <a:lstStyle/>
           <a:p>
             <a:r>
-              <a:t>What would have to be true for NPV to reach zero? Taking one condition at a time: volume of 134,000 cubic metres a year, almost four times an average Dutch plant. Or an average price of 154 euro, 14% above our base, which is already at or above the market. Or a public green premium of 59%, against 1.5% assumed. For our best package the key is the gate fee, the fee a demolition firm pays us to take clean rubble. NPV zero needs about 30 euro a tonne on base terms, or 15 euro if everything else goes our way. Bulk evidence today is 0 to 1 euro. Policy does not close the gap: a levy on primary aggregates hits us as much as competitors, and a faster ETS phase-out hurts. Sources: model extras, results_options.json, MKT-20.</a:t>
+              <a:t>What would have to be true for NPV to reach zero? Taking one condition at a time: volume of 134,000 cubic metres a year, almost four times an average Dutch plant. Or an average price of 154 euro, 14% above our base, which is already at or above the market. Or a public green premium of 58.5%, against 1.5% assumed. For our best package the key is the gate fee, the fee a demolition firm pays us to take clean rubble. NPV zero needs about 30 euro a tonne on base terms, or 15 euro if everything else goes our way. Bulk evidence today is 0 to 1 euro. Policy does not close the gap: a levy on primary aggregates hits us as much as competitors, and a faster ETS phase-out hurts. Sources: model extras, results_options.json, MKT-20.</a:t>
             </a:r>
           </a:p>
         </p:txBody>
@@ -4622,7 +4622,7 @@
                 </a:solidFill>
                 <a:latin typeface="Calibri"/>
               </a:rPr>
-              <a:t>We tested one circular ready-mix plant in Zuid-Holland against four viability tests set in advance. Verdict: NOT VIABLE. Our ask is a €50–100k due-diligence phase, not an investment.</a:t>
+              <a:t>We tested one circular ready-mix plant in Zuid-Holland against four viability tests set in advance. Verdict: NOT VIABLE. Our ask is a €50–100k due-diligence phase, not an investment.</a:t>
             </a:r>
           </a:p>
         </p:txBody>
@@ -5261,7 +5261,7 @@
                 </a:solidFill>
                 <a:latin typeface="Calibri"/>
               </a:rPr>
-              <a:t>Source: model/results.json → sensitivity (one input group at a time, low / high column of inputs.csv); chart model/charts/tornado_npv.png. Price base €135/m³ has confidence L (A-MKT-16).</a:t>
+              <a:t>Source: model/results.json → sensitivity (one input group at a time, low / high column of inputs.csv); chart deck/charts/tornado_npv.png. Price base €135/m³ has confidence L (A-MKT-16).</a:t>
             </a:r>
           </a:p>
         </p:txBody>
@@ -7192,7 +7192,7 @@
                 </a:solidFill>
                 <a:latin typeface="Calibri"/>
               </a:rPr>
-              <a:t>Break-even needs conditions that the Dutch market does not offer today</a:t>
+              <a:t>Reaching NPV = 0 would need conditions that the Dutch market does not offer today</a:t>
             </a:r>
           </a:p>
         </p:txBody>
@@ -7231,7 +7231,7 @@
                 </a:solidFill>
                 <a:latin typeface="Calibri"/>
               </a:rPr>
-              <a:t>Source: model/results.json → extras; results_options.json → P2 stack and policy tests; gate-fee evidence market.md (MKT-20); chart model/charts/breakeven.png (other inputs at base).</a:t>
+              <a:t>Source: model/results.json → extras; results_options.json → P2 stack and policy tests; gate-fee evidence market.md (MKT-20); chart deck/charts/breakeven.png (other inputs at base).</a:t>
             </a:r>
           </a:p>
         </p:txBody>
@@ -7518,7 +7518,7 @@
                           </a:solidFill>
                           <a:latin typeface="Calibri"/>
                         </a:rPr>
-                        <a:t>59% public green premium</a:t>
+                        <a:t>58.5% public green premium</a:t>
                       </a:r>
                     </a:p>
                   </a:txBody>
@@ -11210,7 +11210,7 @@
         <p:spPr>
           <a:xfrm>
             <a:off x="548640" y="4069080"/>
-            <a:ext cx="11094415" cy="1783080"/>
+            <a:ext cx="11094415" cy="1600200"/>
           </a:xfrm>
           <a:prstGeom prst="roundRect">
             <a:avLst>
@@ -15582,7 +15582,7 @@
                 </a:solidFill>
                 <a:latin typeface="Calibri"/>
               </a:rPr>
-              <a:t>Source: model_summary.md §2 (capital recovery over 10 years at 8% real); chart model/charts/ebitda_by_year.png; pass-through rates are key judgement calls (A-POL-09, A-CST-13).</a:t>
+              <a:t>Source: model_summary.md §2 (capital recovery over 10 years at 8% real); chart deck/charts/ebitda_by_year.png; pass-through rates are key judgement calls (A-POL-09, A-CST-13).</a:t>
             </a:r>
           </a:p>
         </p:txBody>
@@ -16195,7 +16195,7 @@
                 </a:solidFill>
                 <a:latin typeface="Calibri"/>
               </a:rPr>
-              <a:t>Source: model/results.json (base case: permits 2026, build 2027, first sales 2028; unlevered; salvage-only terminal value); chart model/charts/cashflow_10yr.png.</a:t>
+              <a:t>Source: model/results.json (base case: permits 2026, build 2027, first sales 2028; unlevered; salvage-only terminal value); chart deck/charts/cashflow_10yr.png.</a:t>
             </a:r>
           </a:p>
         </p:txBody>

</xml_diff>